<commit_message>
feat: add per-slide auto-advance timings to the presentation deck
</commit_message>
<xml_diff>
--- a/presentation/ParaBank_Assessment_Demo.pptx
+++ b/presentation/ParaBank_Assessment_Demo.pptx
@@ -2028,7 +2028,7 @@
                 <a:ea typeface="Trebuchet MS" pitchFamily="34" charset="-122"/>
                 <a:cs typeface="Trebuchet MS" pitchFamily="34" charset="-120"/>
               </a:rPr>
-              <a:t>    |    Software Craftsperson role  -  Incubyte</a:t>
+              <a:t xml:space="preserve">    |    Software Craftsperson role  -  Incubyte</a:t>
             </a:r>
             <a:endParaRPr lang="en-US" sz="1600" dirty="0"/>
           </a:p>
@@ -2067,7 +2067,7 @@
                 <a:ea typeface="Calibri" pitchFamily="34" charset="-122"/>
                 <a:cs typeface="Calibri" pitchFamily="34" charset="-120"/>
               </a:rPr>
-              <a:t>Built with  </a:t>
+              <a:t xml:space="preserve">Built with  </a:t>
             </a:r>
             <a:pPr indent="0" marL="0">
               <a:buNone/>
@@ -2095,7 +2095,7 @@
                 <a:ea typeface="Calibri" pitchFamily="34" charset="-122"/>
                 <a:cs typeface="Calibri" pitchFamily="34" charset="-120"/>
               </a:rPr>
-              <a:t>    -    BDD (Gherkin) + Page Object Model</a:t>
+              <a:t xml:space="preserve">    -    BDD (Gherkin) + Page Object Model</a:t>
             </a:r>
             <a:endParaRPr lang="en-US" sz="1300" dirty="0"/>
           </a:p>
@@ -2145,6 +2145,9 @@
   <p:clrMapOvr>
     <a:masterClrMapping/>
   </p:clrMapOvr>
+  <p:transition advTm="25000">
+    <p:fade/>
+  </p:transition>
 </p:sld>
 </file>
 
@@ -3414,7 +3417,7 @@
                 <a:ea typeface="Calibri" pitchFamily="34" charset="-122"/>
                 <a:cs typeface="Calibri" pitchFamily="34" charset="-120"/>
               </a:rPr>
-              <a:t>Typed code, </a:t>
+              <a:t xml:space="preserve">Typed code, </a:t>
             </a:r>
             <a:pPr indent="0" marL="0">
               <a:buNone/>
@@ -3428,7 +3431,7 @@
                 <a:ea typeface="Calibri" pitchFamily="34" charset="-122"/>
                 <a:cs typeface="Calibri" pitchFamily="34" charset="-120"/>
               </a:rPr>
-              <a:t>small reviewable commits, </a:t>
+              <a:t xml:space="preserve">small reviewable commits, </a:t>
             </a:r>
             <a:pPr indent="0" marL="0">
               <a:buNone/>
@@ -3442,7 +3445,7 @@
                 <a:ea typeface="Calibri" pitchFamily="34" charset="-122"/>
                 <a:cs typeface="Calibri" pitchFamily="34" charset="-120"/>
               </a:rPr>
-              <a:t>reusable steps, a data factory for repeatable runs, CI on every push, and </a:t>
+              <a:t xml:space="preserve">reusable steps, a data factory for repeatable runs, CI on every push, and </a:t>
             </a:r>
             <a:pPr indent="0" marL="0">
               <a:buNone/>
@@ -3545,6 +3548,9 @@
   <p:clrMapOvr>
     <a:masterClrMapping/>
   </p:clrMapOvr>
+  <p:transition advTm="25000">
+    <p:fade/>
+  </p:transition>
 </p:sld>
 </file>
 
@@ -3780,7 +3786,7 @@
                 <a:ea typeface="Calibri" pitchFamily="34" charset="-122"/>
                 <a:cs typeface="Calibri" pitchFamily="34" charset="-120"/>
               </a:rPr>
-              <a:t>33 deep-testing scenarios  </a:t>
+              <a:t xml:space="preserve">33 deep-testing scenarios  </a:t>
             </a:r>
             <a:pPr indent="0" marL="0">
               <a:buNone/>
@@ -3853,7 +3859,7 @@
                 <a:ea typeface="Calibri" pitchFamily="34" charset="-122"/>
                 <a:cs typeface="Calibri" pitchFamily="34" charset="-120"/>
               </a:rPr>
-              <a:t>BDD + Page Object Model  </a:t>
+              <a:t xml:space="preserve">BDD + Page Object Model  </a:t>
             </a:r>
             <a:pPr indent="0" marL="0">
               <a:buNone/>
@@ -3926,7 +3932,7 @@
                 <a:ea typeface="Calibri" pitchFamily="34" charset="-122"/>
                 <a:cs typeface="Calibri" pitchFamily="34" charset="-120"/>
               </a:rPr>
-              <a:t>100% green run  </a:t>
+              <a:t xml:space="preserve">100% green run  </a:t>
             </a:r>
             <a:pPr indent="0" marL="0">
               <a:buNone/>
@@ -3993,7 +3999,7 @@
                 <a:ea typeface="Trebuchet MS" pitchFamily="34" charset="-122"/>
                 <a:cs typeface="Trebuchet MS" pitchFamily="34" charset="-120"/>
               </a:rPr>
-              <a:t>     Software Craftsperson assessment  -  Incubyte</a:t>
+              <a:t xml:space="preserve">     Software Craftsperson assessment  -  Incubyte</a:t>
             </a:r>
             <a:endParaRPr lang="en-US" sz="1500" dirty="0"/>
           </a:p>
@@ -4004,6 +4010,9 @@
   <p:clrMapOvr>
     <a:masterClrMapping/>
   </p:clrMapOvr>
+  <p:transition advTm="20000">
+    <p:fade/>
+  </p:transition>
 </p:sld>
 </file>
 
@@ -4373,7 +4382,7 @@
                 <a:ea typeface="Calibri" pitchFamily="34" charset="-122"/>
                 <a:cs typeface="Calibri" pitchFamily="34" charset="-120"/>
               </a:rPr>
-              <a:t>Functional  </a:t>
+              <a:t xml:space="preserve">Functional  </a:t>
             </a:r>
             <a:pPr indent="0" marL="0">
               <a:buNone/>
@@ -4446,7 +4455,7 @@
                 <a:ea typeface="Calibri" pitchFamily="34" charset="-122"/>
                 <a:cs typeface="Calibri" pitchFamily="34" charset="-120"/>
               </a:rPr>
-              <a:t>Boundary  </a:t>
+              <a:t xml:space="preserve">Boundary  </a:t>
             </a:r>
             <a:pPr indent="0" marL="0">
               <a:buNone/>
@@ -4519,7 +4528,7 @@
                 <a:ea typeface="Calibri" pitchFamily="34" charset="-122"/>
                 <a:cs typeface="Calibri" pitchFamily="34" charset="-120"/>
               </a:rPr>
-              <a:t>Security  </a:t>
+              <a:t xml:space="preserve">Security  </a:t>
             </a:r>
             <a:pPr indent="0" marL="0">
               <a:buNone/>
@@ -4592,7 +4601,7 @@
                 <a:ea typeface="Calibri" pitchFamily="34" charset="-122"/>
                 <a:cs typeface="Calibri" pitchFamily="34" charset="-120"/>
               </a:rPr>
-              <a:t>Performance  </a:t>
+              <a:t xml:space="preserve">Performance  </a:t>
             </a:r>
             <a:pPr indent="0" marL="0">
               <a:buNone/>
@@ -5344,6 +5353,9 @@
   <p:clrMapOvr>
     <a:masterClrMapping/>
   </p:clrMapOvr>
+  <p:transition advTm="40000">
+    <p:fade/>
+  </p:transition>
 </p:sld>
 </file>
 
@@ -6162,7 +6174,7 @@
                 <a:ea typeface="Calibri" pitchFamily="34" charset="-122"/>
                 <a:cs typeface="Calibri" pitchFamily="34" charset="-120"/>
               </a:rPr>
-              <a:t>  compiles the Gherkin feature files into runnable Playwright specs, and custom </a:t>
+              <a:t xml:space="preserve">  compiles the Gherkin feature files into runnable Playwright specs, and custom </a:t>
             </a:r>
             <a:pPr indent="0" marL="0">
               <a:buNone/>
@@ -6190,7 +6202,7 @@
                 <a:ea typeface="Calibri" pitchFamily="34" charset="-122"/>
                 <a:cs typeface="Calibri" pitchFamily="34" charset="-120"/>
               </a:rPr>
-              <a:t> inject ready-to-use page objects into every step - the bridge between BDD and POM.</a:t>
+              <a:t xml:space="preserve"> inject ready-to-use page objects into every step - the bridge between BDD and POM.</a:t>
             </a:r>
             <a:endParaRPr lang="en-US" sz="1300" dirty="0"/>
           </a:p>
@@ -6279,6 +6291,9 @@
   <p:clrMapOvr>
     <a:masterClrMapping/>
   </p:clrMapOvr>
+  <p:transition advTm="40000">
+    <p:fade/>
+  </p:transition>
 </p:sld>
 </file>
 
@@ -7843,6 +7858,9 @@
   <p:clrMapOvr>
     <a:masterClrMapping/>
   </p:clrMapOvr>
+  <p:transition advTm="35000">
+    <p:fade/>
+  </p:transition>
 </p:sld>
 </file>
 
@@ -9121,6 +9139,9 @@
   <p:clrMapOvr>
     <a:masterClrMapping/>
   </p:clrMapOvr>
+  <p:transition advTm="35000">
+    <p:fade/>
+  </p:transition>
 </p:sld>
 </file>
 
@@ -10285,6 +10306,9 @@
   <p:clrMapOvr>
     <a:masterClrMapping/>
   </p:clrMapOvr>
+  <p:transition advTm="45000">
+    <p:fade/>
+  </p:transition>
 </p:sld>
 </file>
 
@@ -11010,6 +11034,9 @@
   <p:clrMapOvr>
     <a:masterClrMapping/>
   </p:clrMapOvr>
+  <p:transition advTm="30000">
+    <p:fade/>
+  </p:transition>
 </p:sld>
 </file>
 
@@ -11789,7 +11816,7 @@
                 <a:ea typeface="Calibri" pitchFamily="34" charset="-122"/>
                 <a:cs typeface="Calibri" pitchFamily="34" charset="-120"/>
               </a:rPr>
-              <a:t>Run on 24 May 2026.  </a:t>
+              <a:t xml:space="preserve">Run on 24 May 2026.  </a:t>
             </a:r>
             <a:pPr indent="0" marL="0">
               <a:buNone/>
@@ -11862,7 +11889,7 @@
                 <a:ea typeface="Calibri" pitchFamily="34" charset="-122"/>
                 <a:cs typeface="Calibri" pitchFamily="34" charset="-120"/>
               </a:rPr>
-              <a:t>Monocart HTML report  </a:t>
+              <a:t xml:space="preserve">Monocart HTML report  </a:t>
             </a:r>
             <a:pPr indent="0" marL="0">
               <a:buNone/>
@@ -11935,7 +11962,7 @@
                 <a:ea typeface="Calibri" pitchFamily="34" charset="-122"/>
                 <a:cs typeface="Calibri" pitchFamily="34" charset="-120"/>
               </a:rPr>
-              <a:t>Plain-English summary  </a:t>
+              <a:t xml:space="preserve">Plain-English summary  </a:t>
             </a:r>
             <a:pPr indent="0" marL="0">
               <a:buNone/>
@@ -12008,7 +12035,7 @@
                 <a:ea typeface="Calibri" pitchFamily="34" charset="-122"/>
                 <a:cs typeface="Calibri" pitchFamily="34" charset="-120"/>
               </a:rPr>
-              <a:t>Execution logs  </a:t>
+              <a:t xml:space="preserve">Execution logs  </a:t>
             </a:r>
             <a:pPr indent="0" marL="0">
               <a:buNone/>
@@ -12111,6 +12138,9 @@
   <p:clrMapOvr>
     <a:masterClrMapping/>
   </p:clrMapOvr>
+  <p:transition advTm="35000">
+    <p:fade/>
+  </p:transition>
 </p:sld>
 </file>
 
@@ -12775,6 +12805,9 @@
   <p:clrMapOvr>
     <a:masterClrMapping/>
   </p:clrMapOvr>
+  <p:transition advTm="45000">
+    <p:fade/>
+  </p:transition>
 </p:sld>
 </file>
 

</xml_diff>

<commit_message>
docs: surface the WORKERS parallel-run option in README, deck, script and test plan
</commit_message>
<xml_diff>
--- a/presentation/ParaBank_Assessment_Demo.pptx
+++ b/presentation/ParaBank_Assessment_Demo.pptx
@@ -870,7 +870,7 @@
           <a:p>
             <a:r>
               <a:rPr lang="en-US" dirty="0"/>
-              <a:t>The results. The full suite ran on the 24th of May - 33 of 33 scenarios passed, zero failures, in about 141 seconds, 100 percent automated. One command runs everything, in Chromium, serially for a stable shared environment, with unique data on every run.</a:t>
+              <a:t>The results. The full suite ran on the 24th of May - 33 of 33 scenarios passed, zero failures, in about 141 seconds, fully automated. It runs serially by default, because the shared ParaBank demo rejects concurrent load - but a single WORKERS flag switches it to parallel execution on a dedicated host, which cuts the run time substantially.</a:t>
             </a:r>
             <a:endParaRPr lang="en-US" dirty="0"/>
           </a:p>
@@ -5903,7 +5903,7 @@
                 <a:ea typeface="Calibri" pitchFamily="34" charset="-122"/>
                 <a:cs typeface="Calibri" pitchFamily="34" charset="-120"/>
               </a:rPr>
-              <a:t xml:space="preserve">One command  </a:t>
+              <a:t xml:space="preserve">Serial by default  </a:t>
             </a:r>
             <a:pPr indent="0" marL="0">
               <a:buNone/>
@@ -5917,7 +5917,35 @@
                 <a:ea typeface="Calibri" pitchFamily="34" charset="-122"/>
                 <a:cs typeface="Calibri" pitchFamily="34" charset="-120"/>
               </a:rPr>
-              <a:t>(npm test)  ·  Chromium  ·  serial, single worker for a stable shared environment  ·  unique data each run.</a:t>
+              <a:t xml:space="preserve">- the shared demo rejects concurrent load.   </a:t>
+            </a:r>
+            <a:pPr indent="0" marL="0">
+              <a:buNone/>
+            </a:pPr>
+            <a:r>
+              <a:rPr lang="en-US" sz="1200" b="1" dirty="0">
+                <a:solidFill>
+                  <a:srgbClr val="FFFFFF"/>
+                </a:solidFill>
+                <a:latin typeface="Calibri" pitchFamily="34" charset="0"/>
+                <a:ea typeface="Calibri" pitchFamily="34" charset="-122"/>
+                <a:cs typeface="Calibri" pitchFamily="34" charset="-120"/>
+              </a:rPr>
+              <a:t>WORKERS=4 npm test</a:t>
+            </a:r>
+            <a:pPr indent="0" marL="0">
+              <a:buNone/>
+            </a:pPr>
+            <a:r>
+              <a:rPr lang="en-US" sz="1200" dirty="0">
+                <a:solidFill>
+                  <a:srgbClr val="9FB0CE"/>
+                </a:solidFill>
+                <a:latin typeface="Calibri" pitchFamily="34" charset="0"/>
+                <a:ea typeface="Calibri" pitchFamily="34" charset="-122"/>
+                <a:cs typeface="Calibri" pitchFamily="34" charset="-120"/>
+              </a:rPr>
+              <a:t xml:space="preserve">  runs it in parallel on a dedicated host, cutting the run time.</a:t>
             </a:r>
             <a:endParaRPr lang="en-US" sz="1200" dirty="0"/>
           </a:p>

</xml_diff>